<commit_message>
Docs: changelog, methodology manual, deployment with the pending migrations, the assessment register
Co-Authored-By: Claude Fable 5.1 <noreply@anthropic.com>
</commit_message>
<xml_diff>
--- a/docs/INFORM_Tanzania_SADC_format.pptx
+++ b/docs/INFORM_Tanzania_SADC_format.pptx
@@ -4270,7 +4270,7 @@
                   <a:srgbClr val="102A43"/>
                 </a:solidFill>
               </a:rPr>
-              <a:t>The Country Model Template — how risk is calculated, the bottleneck, and scaling it to local level</a:t>
+              <a:t>The Country Model Template: how risk is calculated, the bottleneck, and scaling it to local level</a:t>
             </a:r>
           </a:p>
           <a:p>
@@ -4280,7 +4280,7 @@
                   <a:srgbClr val="102A43"/>
                 </a:solidFill>
               </a:rPr>
-              <a:t>Prime Minister's Office – Disaster Management Department (PMO-DMD)</a:t>
+              <a:t>Prime Minister's Office, Disaster Management Department (PMO-DMD)</a:t>
             </a:r>
           </a:p>
         </p:txBody>
@@ -4324,7 +4324,7 @@
           <a:lstStyle/>
           <a:p>
             <a:r>
-              <a:t>Opportunities — research &amp; financial support for member-state adoption</a:t>
+              <a:t>Opportunities: research &amp; financial support for member-state adoption</a:t>
             </a:r>
           </a:p>
         </p:txBody>
@@ -4445,7 +4445,7 @@
                   <a:srgbClr val="1E6F3D"/>
                 </a:solidFill>
               </a:rPr>
-              <a:t>Tanzania as the subnational-INFORM pilot — a shared, open method and data standard for the region.</a:t>
+              <a:t>Tanzania as the subnational-INFORM pilot: a shared, open method and data standard for the region.</a:t>
             </a:r>
           </a:p>
         </p:txBody>
@@ -4515,7 +4515,7 @@
                   <a:srgbClr val="102A43"/>
                 </a:solidFill>
               </a:rPr>
-              <a:t>The Country Model Template math is fully understood and reproduced exactly — 8,664/8,664 cells, 170/170 risks.</a:t>
+              <a:t>The Country Model Template math is fully understood and reproduced exactly: 8,664/8,664 cells, 170/170 risks.</a:t>
             </a:r>
           </a:p>
           <a:p>
@@ -4545,7 +4545,7 @@
                   <a:srgbClr val="102A43"/>
                 </a:solidFill>
               </a:rPr>
-              <a:t>Local-data capture and Earth Observation are working, with each layer validated before use.</a:t>
+              <a:t>Earth-observation layers are shown apart from the Core as a labelled Advancement layer (12 of 25 sub-indicators filled); a composite drought index and a Sentinel-1 flood layer were withdrawn when validation failed.</a:t>
             </a:r>
           </a:p>
           <a:p>
@@ -4659,7 +4659,7 @@
                   <a:srgbClr val="102A43"/>
                 </a:solidFill>
               </a:rPr>
-              <a:t>INFORM is an open composite index of disaster risk — one 0–10 score per area (0 = lowest, 10 = highest). Tanzania runs the regional INFORM Country Model Template (Excel); the national INFORM risk is 4.1.</a:t>
+              <a:t>INFORM is an open composite index of disaster risk: one 0–10 score per area (0 = lowest, 10 = highest). Tanzania runs the regional INFORM Country Model Template (Excel, 2024 release) at 170 district-level units. INFORM publishes no national figure for a subnational model; the INFORM aggregate of all 195 councils on the workbook data is 3.8 (Hazard &amp; Exposure 2.4, Vulnerability 3.8, Lack of Coping 6.2).</a:t>
             </a:r>
           </a:p>
           <a:p>
@@ -4689,7 +4689,7 @@
                   <a:srgbClr val="444C57"/>
                 </a:solidFill>
               </a:rPr>
-              <a:t>Hazard &amp; Exposure — drought, flood, earthquake, cyclone, conflict … and who/what is exposed</a:t>
+              <a:t>Hazard &amp; Exposure: drought, flood, earthquake, cyclone, conflict … and who/what is exposed</a:t>
             </a:r>
           </a:p>
           <a:p>
@@ -4704,7 +4704,7 @@
                   <a:srgbClr val="444C57"/>
                 </a:solidFill>
               </a:rPr>
-              <a:t>Vulnerability — poverty, health, nutrition, food insecurity, displacement</a:t>
+              <a:t>Vulnerability: poverty, health, nutrition, food insecurity, displacement</a:t>
             </a:r>
           </a:p>
           <a:p>
@@ -4719,7 +4719,7 @@
                   <a:srgbClr val="444C57"/>
                 </a:solidFill>
               </a:rPr>
-              <a:t>Lack of Coping Capacity — institutions &amp; infrastructure (DRR, governance, WASH, health, education)</a:t>
+              <a:t>Lack of Coping Capacity: institutions &amp; infrastructure (DRR, governance, WASH, health, education)</a:t>
             </a:r>
           </a:p>
           <a:p>
@@ -4853,7 +4853,7 @@
                   <a:srgbClr val="102A43"/>
                 </a:solidFill>
               </a:rPr>
-              <a:t>2.  Denominator — ÷ population / area / GDP, or none</a:t>
+              <a:t>2.  Denominator: ÷ population / area / GDP, or none</a:t>
             </a:r>
           </a:p>
           <a:p>
@@ -4868,7 +4868,7 @@
                   <a:srgbClr val="102A43"/>
                 </a:solidFill>
               </a:rPr>
-              <a:t>3.  Outlier cap — Tukey IQR fence:  MAX( MIN(x, Q3 + 1.5·IQR) , Q1 − 1.5·IQR )</a:t>
+              <a:t>3.  Outlier cap: Tukey IQR fence:  MAX( MIN(x, Q3 + 1.5·IQR) , Q1 − 1.5·IQR )</a:t>
             </a:r>
           </a:p>
           <a:p>
@@ -4883,7 +4883,7 @@
                   <a:srgbClr val="102A43"/>
                 </a:solidFill>
               </a:rPr>
-              <a:t>4.  Transform — None | Logarithm LN(0.001 + x) | Exponential</a:t>
+              <a:t>4.  Transform: None | Logarithm LN(0.001 + x) | Exponential</a:t>
             </a:r>
           </a:p>
           <a:p>
@@ -4898,7 +4898,7 @@
                   <a:srgbClr val="102A43"/>
                 </a:solidFill>
               </a:rPr>
-              <a:t>5.  Min–max scaling — 10 × (x − Min) / (Max − Min)  against a fixed reference range</a:t>
+              <a:t>5.  Min–max scaling: 10 × (x − Min) / (Max − Min)  against a fixed reference range</a:t>
             </a:r>
           </a:p>
           <a:p>
@@ -4913,7 +4913,7 @@
                   <a:srgbClr val="102A43"/>
                 </a:solidFill>
               </a:rPr>
-              <a:t>6.  Direction — if protective (higher = better): 10 − score</a:t>
+              <a:t>6.  Direction: if protective (higher = better): 10 − score</a:t>
             </a:r>
           </a:p>
           <a:p>
@@ -4943,7 +4943,7 @@
                   <a:srgbClr val="444C57"/>
                 </a:solidFill>
               </a:rPr>
-              <a:t>Every indicator, whatever its unit, passes through the same chain — Tukey outliers, log/exp transform, min–max, direction.</a:t>
+              <a:t>Every indicator, whatever its unit, passes through the same chain: Tukey outliers, log/exp transform, min–max, direction.</a:t>
             </a:r>
           </a:p>
         </p:txBody>
@@ -5007,7 +5007,7 @@
           <a:lstStyle/>
           <a:p>
             <a:r>
-              <a:t>A few indicators — many units (why standardisation is needed)</a:t>
+              <a:t>A few indicators: many units (why standardisation is needed)</a:t>
             </a:r>
           </a:p>
         </p:txBody>
@@ -5135,7 +5135,7 @@
                             <a:srgbClr val="102A43"/>
                           </a:solidFill>
                         </a:rPr>
-                        <a:t>Food security – insufficient food</a:t>
+                        <a:t>Food security: insufficient food</a:t>
                       </a:r>
                     </a:p>
                   </a:txBody>
@@ -5740,7 +5740,7 @@
                   <a:srgbClr val="1E6F3D"/>
                 </a:solidFill>
               </a:rPr>
-              <a:t>%, years, counts, US$, per-1,000, per-10,000, Mg/ha/yr, m/yr — all reconciled onto one 0–10 scale.</a:t>
+              <a:t>%, years, counts, US$, per-1,000, per-10,000, Mg/ha/yr, m/yr: all reconciled onto one 0–10 scale.</a:t>
             </a:r>
           </a:p>
         </p:txBody>
@@ -5803,7 +5803,7 @@
           <a:lstStyle/>
           <a:p>
             <a:r>
-              <a:t>From indicators to risk — categorisation &amp; aggregation</a:t>
+              <a:t>From indicators to risk: categorisation &amp; aggregation</a:t>
             </a:r>
           </a:p>
         </p:txBody>
@@ -5886,7 +5886,7 @@
                   <a:srgbClr val="1E6F3D"/>
                 </a:solidFill>
               </a:rPr>
-              <a:t>Risk  =  ∛ ( H × V × LCC )   — cube-root of the three dimensions</a:t>
+              <a:t>Risk  =  ∛ ( H × V × LCC )  : cube-root of the three dimensions</a:t>
             </a:r>
           </a:p>
           <a:p>
@@ -5916,7 +5916,7 @@
                   <a:srgbClr val="102A43"/>
                 </a:solidFill>
               </a:rPr>
-              <a:t>The geometric mean matters: a unit cannot "average away" one very weak dimension — high hazard with low coping capacity still yields high risk.</a:t>
+              <a:t>The geometric mean matters: a unit cannot "average away" one very weak dimension: high hazard with low coping capacity still yields high risk.</a:t>
             </a:r>
           </a:p>
         </p:txBody>
@@ -6032,7 +6032,7 @@
                   <a:srgbClr val="102A43"/>
                 </a:solidFill>
               </a:rPr>
-              <a:t>Opaque — the math is invisible to the people who must use and trust the numbers.</a:t>
+              <a:t>Opaque: the math is invisible to the people who must use and trust the numbers.</a:t>
             </a:r>
           </a:p>
           <a:p>
@@ -6047,7 +6047,7 @@
                   <a:srgbClr val="102A43"/>
                 </a:solidFill>
               </a:rPr>
-              <a:t>Fixed unit set — built for ~170 districts; it cannot scale to 195 councils, wards or villages.</a:t>
+              <a:t>Fixed unit set: built for ~170 districts; it cannot scale to 195 councils, wards or villages.</a:t>
             </a:r>
           </a:p>
           <a:p>
@@ -6062,7 +6062,7 @@
                   <a:srgbClr val="102A43"/>
                 </a:solidFill>
               </a:rPr>
-              <a:t>Manual &amp; single-file — one workbook, no version control, easy to break, hard to audit.</a:t>
+              <a:t>Manual &amp; single-file: one workbook, no version control, easy to break, hard to audit.</a:t>
             </a:r>
           </a:p>
           <a:p>
@@ -6077,7 +6077,7 @@
                   <a:srgbClr val="102A43"/>
                 </a:solidFill>
               </a:rPr>
-              <a:t>Closed to local data — no clean way to add a local indicator or feed council-level values.</a:t>
+              <a:t>Closed to local data: no clean way to add a local indicator or feed council-level values.</a:t>
             </a:r>
           </a:p>
           <a:p>
@@ -6092,7 +6092,7 @@
                   <a:srgbClr val="102A43"/>
                 </a:solidFill>
               </a:rPr>
-              <a:t>No automation — no live update, no link to early warning or anticipatory action.</a:t>
+              <a:t>No automation: no live update, no link to early warning or anticipatory action.</a:t>
             </a:r>
           </a:p>
           <a:p>
@@ -6107,7 +6107,7 @@
                   <a:srgbClr val="B42318"/>
                 </a:solidFill>
               </a:rPr>
-              <a:t>Result: the model stops at national / regional level. Local risk — where decisions are made — is out of reach.</a:t>
+              <a:t>Result: the model stops at its 170 district-level units of 2024. Council, ward and village risk, where decisions are made, is out of reach.</a:t>
             </a:r>
           </a:p>
         </p:txBody>
@@ -6151,7 +6151,7 @@
           <a:lstStyle/>
           <a:p>
             <a:r>
-              <a:t>We rebuilt the hidden sheets as an engine — proven identical, built to scale</a:t>
+              <a:t>We rebuilt the hidden sheets as an engine: proven identical, built to scale</a:t>
             </a:r>
           </a:p>
         </p:txBody>
@@ -6242,7 +6242,7 @@
                   <a:srgbClr val="102A43"/>
                 </a:solidFill>
               </a:rPr>
-              <a:t>Now it scales — the same engine runs unchanged on 195 councils and 31 regions.</a:t>
+              <a:t>Now it scales: the same engine runs unchanged on 195 councils and 31 regions.</a:t>
             </a:r>
           </a:p>
           <a:p>
@@ -6257,7 +6257,7 @@
                   <a:srgbClr val="102A43"/>
                 </a:solidFill>
               </a:rPr>
-              <a:t>Spec-driven &amp; transparent — add, delete or amend an indicator without touching the math; fully testable.</a:t>
+              <a:t>Spec-driven &amp; transparent: add, delete or amend an indicator without touching the math; fully testable.</a:t>
             </a:r>
           </a:p>
           <a:p>
@@ -6272,7 +6272,7 @@
                   <a:srgbClr val="102A43"/>
                 </a:solidFill>
               </a:rPr>
-              <a:t>The regional INFORM core is never altered — it is reproduced exactly; everything new is additive.</a:t>
+              <a:t>The regional INFORM core is never altered: it is reproduced exactly; everything new is additive.</a:t>
             </a:r>
           </a:p>
         </p:txBody>
@@ -6311,7 +6311,7 @@
           <a:lstStyle/>
           <a:p>
             <a:r>
-              <a:t>Capturing real local data — the methods</a:t>
+              <a:t>Capturing real local data: the methods</a:t>
             </a:r>
           </a:p>
         </p:txBody>
@@ -6342,7 +6342,7 @@
                   <a:srgbClr val="102A43"/>
                 </a:solidFill>
               </a:rPr>
-              <a:t>Federated collection tools — one shared Excel per sector; they enter ACTUAL values in natural units and a locked formula shows the 0–10 live.</a:t>
+              <a:t>Federated collection tools: one shared Excel per sector; they enter ACTUAL values in natural units and a locked formula shows the 0–10 live.</a:t>
             </a:r>
           </a:p>
           <a:p>
@@ -6357,7 +6357,7 @@
                   <a:srgbClr val="102A43"/>
                 </a:solidFill>
               </a:rPr>
-              <a:t>One accountable stakeholder per indicator — TMA (climate), GST (geology), NEMC (environment), MoH (health), NBS (statistics), MoA/MUCHALI (food), MoW (water), PMO-DMD (DRR).</a:t>
+              <a:t>One accountable stakeholder per indicator: TMA (climate), GST (geology), NEMC (environment), MoH (health), NBS (statistics), MoA/MUCHALI (food), MoW (water), PMO-DMD (DRR).</a:t>
             </a:r>
           </a:p>
           <a:p>
@@ -6372,7 +6372,7 @@
                   <a:srgbClr val="102A43"/>
                 </a:solidFill>
               </a:rPr>
-              <a:t>Bottom-up aggregation — village → district → region → country; finer, well-filled data refines the higher level.</a:t>
+              <a:t>Bottom-up aggregation: village → district → region → country; finer, well-filled data refines the higher level.</a:t>
             </a:r>
           </a:p>
           <a:p>
@@ -6387,7 +6387,22 @@
                   <a:srgbClr val="102A43"/>
                 </a:solidFill>
               </a:rPr>
-              <a:t>Authentic sources — NBS 2022 Census, TMA CHIRPS/ERA5, GST seismic, MoH TDHS, IPC/MUCHALI, TASAF, and satellite Earth Observation (validated before use).</a:t>
+              <a:t>Authentic sources: NBS 2022 Census, TMA CHIRPS/ERA5, GST seismic, MoH TDHS, IPC/MUCHALI, TASAF, and satellite Earth Observation (validated before use).</a:t>
+            </a:r>
+          </a:p>
+          <a:p>
+            <a:pPr>
+              <a:spcAft>
+                <a:spcPts val="500"/>
+              </a:spcAft>
+            </a:pPr>
+            <a:r>
+              <a:rPr sz="1600" b="1">
+                <a:solidFill>
+                  <a:srgbClr val="1E6F3D"/>
+                </a:solidFill>
+              </a:rPr>
+              <a:t>The regional INFORM core is never altered. Institutional values enter by the INFORM method with a citable source; every other Tanzanian addition is shown in a separate Advancement layer.</a:t>
             </a:r>
           </a:p>
         </p:txBody>
@@ -6426,7 +6441,7 @@
           <a:lstStyle/>
           <a:p>
             <a:r>
-              <a:t>The gap — what still has to be solved</a:t>
+              <a:t>The gap: what still has to be solved</a:t>
             </a:r>
           </a:p>
         </p:txBody>
@@ -6457,7 +6472,7 @@
                   <a:srgbClr val="B42318"/>
                 </a:solidFill>
               </a:rPr>
-              <a:t>Subnational risk is not yet operational — decisions happen at council / ward level, but INFORM stops at national / regional.</a:t>
+              <a:t>Subnational risk is not yet operational: decisions happen at council / ward level, but the regional INFORM model stops at 170 district-level units.</a:t>
             </a:r>
           </a:p>
           <a:p>
@@ -6472,7 +6487,7 @@
                   <a:srgbClr val="102A43"/>
                 </a:solidFill>
               </a:rPr>
-              <a:t>Local data is scattered and uneven — many key indicators exist only at region or national level.</a:t>
+              <a:t>Local data is scattered and uneven: many key indicators exist only at region or national level.</a:t>
             </a:r>
           </a:p>
           <a:p>
@@ -6487,7 +6502,7 @@
                   <a:srgbClr val="102A43"/>
                 </a:solidFill>
               </a:rPr>
-              <a:t>No sustainable pipeline — capturing, validating and updating local data is still manual.</a:t>
+              <a:t>No sustainable pipeline: capturing, validating and updating local data is still manual.</a:t>
             </a:r>
           </a:p>
           <a:p>
@@ -6517,7 +6532,7 @@
                   <a:srgbClr val="102A43"/>
                 </a:solidFill>
               </a:rPr>
-              <a:t>No live link to action — risk is not yet wired to the emergency operations centre, early warning, or local planning &amp; budgeting.</a:t>
+              <a:t>No live link to action: risk is not yet wired to the emergency operations centre, early warning, or local planning &amp; budgeting.</a:t>
             </a:r>
           </a:p>
           <a:p>
@@ -6532,7 +6547,7 @@
                   <a:srgbClr val="102A43"/>
                 </a:solidFill>
               </a:rPr>
-              <a:t>Capacity &amp; financing gaps at local-government level — tools, training and incentives to keep the data flowing.</a:t>
+              <a:t>Capacity &amp; financing gaps at local-government level: tools, training and incentives to keep the data flowing.</a:t>
             </a:r>
           </a:p>
         </p:txBody>

</xml_diff>